<commit_message>
Update Nov 13 webinar files: Caring for the Caregiver (flyers, deck, notes)
</commit_message>
<xml_diff>
--- a/assets/Caregiver-Webinar-Nov13.pptx
+++ b/assets/Caregiver-Webinar-Nov13.pptx
@@ -18,7 +18,6 @@
     <p:sldId id="266" r:id="rId18"/>
     <p:sldId id="267" r:id="rId19"/>
     <p:sldId id="268" r:id="rId20"/>
-    <p:sldId id="269" r:id="rId21"/>
   </p:sldIdLst>
   <p:sldSz cx="12191695" cy="6858000" type="screen4x3"/>
   <p:notesSz cx="6858000" cy="9144000"/>
@@ -515,7 +514,7 @@
           <a:lstStyle/>
           <a:p>
             <a:r>
-              <a:t>[Minutes 0–2] Welcome everyone. Say: November is Family Caregivers Month, and tonight is for YOU — the parents and caregivers who help everyone else. Thank them for coming. Remind them: no cost, no sales pitch, and questions at the end — the ones sent in when they registered come first.</a:t>
+              <a:t>[Minutes 0–2] Welcome everyone. Say: November is Family Caregivers Month, and tonight is different — tonight is not a class about forms. Tonight is for YOU, the ones who help everyone else. No cost, no sales pitch. Questions at the end; the ones sent in at registration come first.</a:t>
             </a:r>
           </a:p>
         </p:txBody>
@@ -585,7 +584,7 @@
           <a:lstStyle/>
           <a:p>
             <a:r>
-              <a:t>[Minutes 27–30] Remind them 2-1-1 is free and local. Respite is not giving up — it is how caregivers last. Encourage one small ask this month.</a:t>
+              <a:t>[Minutes 30–33] Many parents have never heard the word respite. A rested caregiver is a safer caregiver. Encourage one small ask this month.</a:t>
             </a:r>
           </a:p>
         </p:txBody>
@@ -655,7 +654,7 @@
           <a:lstStyle/>
           <a:p>
             <a:r>
-              <a:t>[Minutes 30–33] This is Southern Oak's specialty. A plan takes all the pieces families carry in their heads and puts them in order, with next steps. No prices tonight — the first talk is free and that is where we look at your family.</a:t>
+              <a:t>[Minutes 33–35] End the teaching with one doable step, not pressure. Then move to questions.</a:t>
             </a:r>
           </a:p>
         </p:txBody>
@@ -725,7 +724,7 @@
           <a:lstStyle/>
           <a:p>
             <a:r>
-              <a:t>[Minutes 33–35] End teaching with action, not pressure. One small step this week. Then move to questions.</a:t>
+              <a:t>[Minutes 35–45] Registered questions first, as promised. Keep group answers general; private details belong in the free talk.</a:t>
             </a:r>
           </a:p>
         </p:txBody>
@@ -795,77 +794,7 @@
           <a:lstStyle/>
           <a:p>
             <a:r>
-              <a:t>[Minutes 35–45] Answer registered questions first, like we promise. Keep answers general. If a question needs a family's private details, invite them to the free talk instead of answering it in the group.</a:t>
-            </a:r>
-          </a:p>
-        </p:txBody>
-      </p:sp>
-      <p:sp>
-        <p:nvSpPr>
-          <p:cNvPr id="4" name="Slide Number Placeholder 3"/>
-          <p:cNvSpPr>
-            <a:spLocks noGrp="1"/>
-          </p:cNvSpPr>
-          <p:nvPr>
-            <p:ph type="sldNum" idx="5" sz="quarter"/>
-          </p:nvPr>
-        </p:nvSpPr>
-        <p:spPr/>
-      </p:sp>
-    </p:spTree>
-  </p:cSld>
-  <p:clrMapOvr>
-    <a:masterClrMapping/>
-  </p:clrMapOvr>
-</p:notes>
-</file>
-
-<file path=ppt/notesSlides/notesSlide14.xml><?xml version="1.0" encoding="utf-8"?>
-<p:notes xmlns:a="http://schemas.openxmlformats.org/drawingml/2006/main" xmlns:p="http://schemas.openxmlformats.org/presentationml/2006/main" xmlns:r="http://schemas.openxmlformats.org/officeDocument/2006/relationships">
-  <p:cSld>
-    <p:spTree>
-      <p:nvGrpSpPr>
-        <p:cNvPr id="1" name=""/>
-        <p:cNvGrpSpPr/>
-        <p:nvPr/>
-      </p:nvGrpSpPr>
-      <p:grpSpPr>
-        <a:xfrm>
-          <a:off x="0" y="0"/>
-          <a:ext cx="0" cy="0"/>
-          <a:chOff x="0" y="0"/>
-          <a:chExt cx="0" cy="0"/>
-        </a:xfrm>
-      </p:grpSpPr>
-      <p:sp>
-        <p:nvSpPr>
-          <p:cNvPr id="2" name="Slide Image Placeholder 1"/>
-          <p:cNvSpPr>
-            <a:spLocks noGrp="1"/>
-          </p:cNvSpPr>
-          <p:nvPr>
-            <p:ph type="sldImg" idx="2"/>
-          </p:nvPr>
-        </p:nvSpPr>
-        <p:spPr/>
-      </p:sp>
-      <p:sp>
-        <p:nvSpPr>
-          <p:cNvPr id="3" name="Notes Placeholder 2"/>
-          <p:cNvSpPr>
-            <a:spLocks noGrp="1"/>
-          </p:cNvSpPr>
-          <p:nvPr>
-            <p:ph type="body" idx="3" sz="quarter"/>
-          </p:nvPr>
-        </p:nvSpPr>
-        <p:spPr/>
-        <p:txBody>
-          <a:bodyPr/>
-          <a:lstStyle/>
-          <a:p>
-            <a:r>
-              <a:t>[Close] Thank them warmly. Say Happy Thanksgiving. Remind them the first talk is free and there is no pressure — we are here when they are ready.</a:t>
+              <a:t>[Close] Thank them warmly and say Happy Thanksgiving. Remind them: the medication check and the first talk are free — we are here when they are ready.</a:t>
             </a:r>
           </a:p>
         </p:txBody>
@@ -935,7 +864,7 @@
           <a:lstStyle/>
           <a:p>
             <a:r>
-              <a:t>[Minutes 2–3] Read the road map out loud so families know where the night is going. Tell them a pen and paper will help for the tips.</a:t>
+              <a:t>[Minutes 2–3] Read the road map out loud. Tell them: everything tonight is something you can do from home — this whole night was built for real caregiver life.</a:t>
             </a:r>
           </a:p>
         </p:txBody>
@@ -1005,7 +934,7 @@
           <a:lstStyle/>
           <a:p>
             <a:r>
-              <a:t>[Minutes 3–6] Speak from the heart here. Many parents never hear this. Say: the best thing you can give your child is a caregiver who is still standing. Tonight we cover your child's benefits AND your own load.</a:t>
+              <a:t>[Minutes 3–6] Speak from the heart. Many parents never hear anyone say this out loud. This is the heart of the night — slow down here.</a:t>
             </a:r>
           </a:p>
         </p:txBody>
@@ -1075,7 +1004,7 @@
           <a:lstStyle/>
           <a:p>
             <a:r>
-              <a:t>[Minutes 6–8] Set up the map. Say: these three get mixed up all the time. Tonight we keep it simple — what each one is and who it is for. Details for one family belong in a free first talk, not a group class.</a:t>
+              <a:t>[Minutes 6–10] Read the signs slowly — let them land. Say: if you nodded at two or more, tonight matters for you. Running on empty is normal for caregivers; it is not weakness, and it is not forever.</a:t>
             </a:r>
           </a:p>
         </p:txBody>
@@ -1145,7 +1074,7 @@
           <a:lstStyle/>
           <a:p>
             <a:r>
-              <a:t>[Minutes 8–11] Plain words only. SSI looks at the disability AND the money side. For a child, the parents' income counts too. Never promise anyone they will be approved — SSA decides.</a:t>
+              <a:t>[Minutes 10–14] Practical and doable tonight. One list ends so much daily stress — no more guessing at the pharmacy or the doctor's office.</a:t>
             </a:r>
           </a:p>
         </p:txBody>
@@ -1215,7 +1144,7 @@
           <a:lstStyle/>
           <a:p>
             <a:r>
-              <a:t>[Minutes 11–14] DAC is the one families miss most. Key line: if a parent is about to file for retirement, talk to us FIRST — the order of filings can protect the child's Medicaid. Never promise amounts; SSA decides.</a:t>
+              <a:t>[Minutes 14–18] This is the help caregivers look for most: medication costs. Explain plainly what the check is and that it costs nothing. Invite them to book one after class — first talk is free too.</a:t>
             </a:r>
           </a:p>
         </p:txBody>
@@ -1285,7 +1214,7 @@
           <a:lstStyle/>
           <a:p>
             <a:r>
-              <a:t>[Minutes 14–17] Walk through the three questions slowly. These answers point to the right door. Tell them: you do not have to figure this out alone tonight — that is what the free talk is for.</a:t>
+              <a:t>[Minutes 18–23] Gentle, no shame about money — ever. One page of bills is the start of every budget we build with a family. Just teach the step tonight; prices stay out of the class.</a:t>
             </a:r>
           </a:p>
         </p:txBody>
@@ -1355,7 +1284,7 @@
           <a:lstStyle/>
           <a:p>
             <a:r>
-              <a:t>[Minutes 17–22] This is real help families can use right away. Explain what a check is: we look at the full list, look for help programs, and show you the steps. The check itself is free for everyone.</a:t>
+              <a:t>[Minutes 23–27] Families are surprised this works. Phone, internet, and medical bills are the best first calls. The worst they can say is no — and often they say yes.</a:t>
             </a:r>
           </a:p>
         </p:txBody>
@@ -1425,7 +1354,7 @@
           <a:lstStyle/>
           <a:p>
             <a:r>
-              <a:t>[Minutes 22–27] Keep it gentle — no shame about money, ever. Share the call-companies tip: many companies have hardship or discount programs, but you have to ask. That one call can free up real money.</a:t>
+              <a:t>[Minutes 27–30] 2-1-1 is the front door to local help and Southern Oak is joining its listings. Tell them to save the number in their phone tonight.</a:t>
             </a:r>
           </a:p>
         </p:txBody>
@@ -4529,7 +4458,7 @@
                 </a:solidFill>
                 <a:latin typeface="Georgia"/>
               </a:rPr>
-              <a:t>Thankful Hearts, Clear Steps</a:t>
+              <a:t>Caring for the Caregiver</a:t>
             </a:r>
           </a:p>
         </p:txBody>
@@ -4564,7 +4493,7 @@
                 </a:solidFill>
                 <a:latin typeface="Calibri"/>
               </a:rPr>
-              <a:t>Help for the Ones Who Help Everyone Else</a:t>
+              <a:t>A Night for the Ones Who Help Everyone Else</a:t>
             </a:r>
           </a:p>
         </p:txBody>
@@ -4775,7 +4704,7 @@
                 </a:solidFill>
                 <a:latin typeface="Georgia"/>
               </a:rPr>
-              <a:t>Asking for Help Is a Strength</a:t>
+              <a:t>Real Breaks: Respite</a:t>
             </a:r>
           </a:p>
         </p:txBody>
@@ -4810,7 +4739,7 @@
                 </a:solidFill>
                 <a:latin typeface="Calibri"/>
               </a:rPr>
-              <a:t>•  Dial 2-1-1 for local help — food, bills, respite and more</a:t>
+              <a:t>•  Respite means a trained person stays with your child</a:t>
             </a:r>
           </a:p>
           <a:p>
@@ -4822,7 +4751,7 @@
                 </a:solidFill>
                 <a:latin typeface="Calibri"/>
               </a:rPr>
-              <a:t>•  Respite care gives caregivers a real break</a:t>
+              <a:t>•  So you can rest, shop, or just breathe</a:t>
             </a:r>
           </a:p>
           <a:p>
@@ -4834,7 +4763,7 @@
                 </a:solidFill>
                 <a:latin typeface="Calibri"/>
               </a:rPr>
-              <a:t>•  Parent groups understand your life like no one else</a:t>
+              <a:t>•  Ask 2-1-1 and your local disability organizations</a:t>
             </a:r>
           </a:p>
           <a:p>
@@ -4846,7 +4775,7 @@
                 </a:solidFill>
                 <a:latin typeface="Calibri"/>
               </a:rPr>
-              <a:t>•  Accepting help protects your whole family</a:t>
+              <a:t>•  A break is not giving up — it is how caregivers last</a:t>
             </a:r>
           </a:p>
         </p:txBody>
@@ -5022,7 +4951,7 @@
                 </a:solidFill>
                 <a:latin typeface="Georgia"/>
               </a:rPr>
-              <a:t>Your Child's Personal Plan</a:t>
+              <a:t>One Small Break This Month</a:t>
             </a:r>
           </a:p>
         </p:txBody>
@@ -5057,7 +4986,7 @@
                 </a:solidFill>
                 <a:latin typeface="Calibri"/>
               </a:rPr>
-              <a:t>•  A plan made only for YOUR child — no two are the same</a:t>
+              <a:t>•  Pick ONE small thing:</a:t>
             </a:r>
           </a:p>
           <a:p>
@@ -5069,7 +4998,7 @@
                 </a:solidFill>
                 <a:latin typeface="Calibri"/>
               </a:rPr>
-              <a:t>•  It covers benefits, medication, school steps and the future</a:t>
+              <a:t>•  One hour that is only yours</a:t>
             </a:r>
           </a:p>
           <a:p>
@@ -5081,7 +5010,7 @@
                 </a:solidFill>
                 <a:latin typeface="Calibri"/>
               </a:rPr>
-              <a:t>•  For ages 5 to 26 — child plans and young-adult transition</a:t>
+              <a:t>•  One call — 2-1-1, the pharmacy, or a bill company</a:t>
             </a:r>
           </a:p>
           <a:p>
@@ -5093,7 +5022,19 @@
                 </a:solidFill>
                 <a:latin typeface="Calibri"/>
               </a:rPr>
-              <a:t>•  It grows and updates as your child's life changes</a:t>
+              <a:t>•  One page — the medication list or the bill list</a:t>
+            </a:r>
+          </a:p>
+          <a:p>
+            <a:pPr algn="l"/>
+            <a:r>
+              <a:rPr sz="2700" b="0">
+                <a:solidFill>
+                  <a:srgbClr val="222222"/>
+                </a:solidFill>
+                <a:latin typeface="Calibri"/>
+              </a:rPr>
+              <a:t>•  Small is enough. Start there.</a:t>
             </a:r>
           </a:p>
         </p:txBody>
@@ -5269,7 +5210,7 @@
                 </a:solidFill>
                 <a:latin typeface="Georgia"/>
               </a:rPr>
-              <a:t>One Small Step This Week</a:t>
+              <a:t>Questions</a:t>
             </a:r>
           </a:p>
         </p:txBody>
@@ -5304,7 +5245,7 @@
                 </a:solidFill>
                 <a:latin typeface="Calibri"/>
               </a:rPr>
-              <a:t>•  Pick ONE — small is enough:</a:t>
+              <a:t>•  Questions sent in at registration come first</a:t>
             </a:r>
           </a:p>
           <a:p>
@@ -5316,7 +5257,7 @@
                 </a:solidFill>
                 <a:latin typeface="Calibri"/>
               </a:rPr>
-              <a:t>•  Book your free first talk</a:t>
+              <a:t>•  Then open questions</a:t>
             </a:r>
           </a:p>
           <a:p>
@@ -5328,31 +5269,7 @@
                 </a:solidFill>
                 <a:latin typeface="Calibri"/>
               </a:rPr>
-              <a:t>•  Ask for your free medication check</a:t>
-            </a:r>
-          </a:p>
-          <a:p>
-            <a:pPr algn="l"/>
-            <a:r>
-              <a:rPr sz="2700" b="0">
-                <a:solidFill>
-                  <a:srgbClr val="222222"/>
-                </a:solidFill>
-                <a:latin typeface="Calibri"/>
-              </a:rPr>
-              <a:t>•  Call 2-1-1 and ask what help is near you</a:t>
-            </a:r>
-          </a:p>
-          <a:p>
-            <a:pPr algn="l"/>
-            <a:r>
-              <a:rPr sz="2700" b="0">
-                <a:solidFill>
-                  <a:srgbClr val="222222"/>
-                </a:solidFill>
-                <a:latin typeface="Calibri"/>
-              </a:rPr>
-              <a:t>•  Write your child's medication list on one page</a:t>
+              <a:t>•  Personal cases: book your free first talk — we keep private things private</a:t>
             </a:r>
           </a:p>
         </p:txBody>
@@ -5456,241 +5373,6 @@
       </p:sp>
       <p:sp>
         <p:nvSpPr>
-          <p:cNvPr id="3" name="Rectangle 2"/>
-          <p:cNvSpPr/>
-          <p:nvPr/>
-        </p:nvSpPr>
-        <p:spPr>
-          <a:xfrm>
-            <a:off x="0" y="0"/>
-            <a:ext cx="12191695" cy="1051560"/>
-          </a:xfrm>
-          <a:prstGeom prst="rect">
-            <a:avLst/>
-          </a:prstGeom>
-          <a:solidFill>
-            <a:srgbClr val="2E4A2B"/>
-          </a:solidFill>
-          <a:ln>
-            <a:noFill/>
-          </a:ln>
-          <a:effectLst/>
-        </p:spPr>
-        <p:style>
-          <a:lnRef idx="1">
-            <a:schemeClr val="accent1"/>
-          </a:lnRef>
-          <a:fillRef idx="3">
-            <a:schemeClr val="accent1"/>
-          </a:fillRef>
-          <a:effectRef idx="2">
-            <a:schemeClr val="accent1"/>
-          </a:effectRef>
-          <a:fontRef idx="minor">
-            <a:schemeClr val="lt1"/>
-          </a:fontRef>
-        </p:style>
-        <p:txBody>
-          <a:bodyPr rtlCol="0" anchor="ctr"/>
-          <a:lstStyle/>
-          <a:p>
-            <a:pPr algn="ctr"/>
-          </a:p>
-        </p:txBody>
-      </p:sp>
-      <p:sp>
-        <p:nvSpPr>
-          <p:cNvPr id="4" name="TextBox 3"/>
-          <p:cNvSpPr txBox="1"/>
-          <p:nvPr/>
-        </p:nvSpPr>
-        <p:spPr>
-          <a:xfrm>
-            <a:off x="548640" y="164592"/>
-            <a:ext cx="11064240" cy="777240"/>
-          </a:xfrm>
-          <a:prstGeom prst="rect">
-            <a:avLst/>
-          </a:prstGeom>
-          <a:noFill/>
-        </p:spPr>
-        <p:txBody>
-          <a:bodyPr wrap="square">
-            <a:spAutoFit/>
-          </a:bodyPr>
-          <a:lstStyle/>
-          <a:p>
-            <a:pPr algn="l"/>
-            <a:r>
-              <a:rPr sz="4000" b="1">
-                <a:solidFill>
-                  <a:srgbClr val="FFFFFF"/>
-                </a:solidFill>
-                <a:latin typeface="Georgia"/>
-              </a:rPr>
-              <a:t>Questions</a:t>
-            </a:r>
-          </a:p>
-        </p:txBody>
-      </p:sp>
-      <p:sp>
-        <p:nvSpPr>
-          <p:cNvPr id="5" name="TextBox 4"/>
-          <p:cNvSpPr txBox="1"/>
-          <p:nvPr/>
-        </p:nvSpPr>
-        <p:spPr>
-          <a:xfrm>
-            <a:off x="822960" y="1554480"/>
-            <a:ext cx="10607040" cy="4480560"/>
-          </a:xfrm>
-          <a:prstGeom prst="rect">
-            <a:avLst/>
-          </a:prstGeom>
-          <a:noFill/>
-        </p:spPr>
-        <p:txBody>
-          <a:bodyPr wrap="square">
-            <a:spAutoFit/>
-          </a:bodyPr>
-          <a:lstStyle/>
-          <a:p>
-            <a:pPr algn="l"/>
-            <a:r>
-              <a:rPr sz="2700" b="0">
-                <a:solidFill>
-                  <a:srgbClr val="222222"/>
-                </a:solidFill>
-                <a:latin typeface="Calibri"/>
-              </a:rPr>
-              <a:t>•  Questions sent in at registration come first</a:t>
-            </a:r>
-          </a:p>
-          <a:p>
-            <a:pPr algn="l"/>
-            <a:r>
-              <a:rPr sz="2700" b="0">
-                <a:solidFill>
-                  <a:srgbClr val="222222"/>
-                </a:solidFill>
-                <a:latin typeface="Calibri"/>
-              </a:rPr>
-              <a:t>•  Then open questions</a:t>
-            </a:r>
-          </a:p>
-          <a:p>
-            <a:pPr algn="l"/>
-            <a:r>
-              <a:rPr sz="2700" b="0">
-                <a:solidFill>
-                  <a:srgbClr val="222222"/>
-                </a:solidFill>
-                <a:latin typeface="Calibri"/>
-              </a:rPr>
-              <a:t>•  Personal cases: book your free first talk — we keep private things private</a:t>
-            </a:r>
-          </a:p>
-        </p:txBody>
-      </p:sp>
-      <p:sp>
-        <p:nvSpPr>
-          <p:cNvPr id="6" name="TextBox 5"/>
-          <p:cNvSpPr txBox="1"/>
-          <p:nvPr/>
-        </p:nvSpPr>
-        <p:spPr>
-          <a:xfrm>
-            <a:off x="548640" y="6355080"/>
-            <a:ext cx="11064240" cy="365760"/>
-          </a:xfrm>
-          <a:prstGeom prst="rect">
-            <a:avLst/>
-          </a:prstGeom>
-          <a:noFill/>
-        </p:spPr>
-        <p:txBody>
-          <a:bodyPr wrap="square">
-            <a:spAutoFit/>
-          </a:bodyPr>
-          <a:lstStyle/>
-          <a:p>
-            <a:pPr algn="l"/>
-            <a:r>
-              <a:rPr sz="1400" b="0">
-                <a:solidFill>
-                  <a:srgbClr val="2E4A2B"/>
-                </a:solidFill>
-                <a:latin typeface="Calibri"/>
-              </a:rPr>
-              <a:t>Southern Oak Financial &amp; Wellness — Free Zoom Webinar</a:t>
-            </a:r>
-          </a:p>
-        </p:txBody>
-      </p:sp>
-    </p:spTree>
-  </p:cSld>
-  <p:clrMapOvr>
-    <a:masterClrMapping/>
-  </p:clrMapOvr>
-</p:sld>
-</file>
-
-<file path=ppt/slides/slide14.xml><?xml version="1.0" encoding="utf-8"?>
-<p:sld xmlns:a="http://schemas.openxmlformats.org/drawingml/2006/main" xmlns:p="http://schemas.openxmlformats.org/presentationml/2006/main" xmlns:r="http://schemas.openxmlformats.org/officeDocument/2006/relationships">
-  <p:cSld>
-    <p:spTree>
-      <p:nvGrpSpPr>
-        <p:cNvPr id="1" name=""/>
-        <p:cNvGrpSpPr/>
-        <p:nvPr/>
-      </p:nvGrpSpPr>
-      <p:grpSpPr/>
-      <p:sp>
-        <p:nvSpPr>
-          <p:cNvPr id="2" name="Rectangle 1"/>
-          <p:cNvSpPr/>
-          <p:nvPr/>
-        </p:nvSpPr>
-        <p:spPr>
-          <a:xfrm>
-            <a:off x="0" y="0"/>
-            <a:ext cx="12191695" cy="6858000"/>
-          </a:xfrm>
-          <a:prstGeom prst="rect">
-            <a:avLst/>
-          </a:prstGeom>
-          <a:solidFill>
-            <a:srgbClr val="FAF4E6"/>
-          </a:solidFill>
-          <a:ln>
-            <a:noFill/>
-          </a:ln>
-          <a:effectLst/>
-        </p:spPr>
-        <p:style>
-          <a:lnRef idx="1">
-            <a:schemeClr val="accent1"/>
-          </a:lnRef>
-          <a:fillRef idx="3">
-            <a:schemeClr val="accent1"/>
-          </a:fillRef>
-          <a:effectRef idx="2">
-            <a:schemeClr val="accent1"/>
-          </a:effectRef>
-          <a:fontRef idx="minor">
-            <a:schemeClr val="lt1"/>
-          </a:fontRef>
-        </p:style>
-        <p:txBody>
-          <a:bodyPr rtlCol="0" anchor="ctr"/>
-          <a:lstStyle/>
-          <a:p>
-            <a:pPr algn="ctr"/>
-          </a:p>
-        </p:txBody>
-      </p:sp>
-      <p:sp>
-        <p:nvSpPr>
           <p:cNvPr id="3" name="TextBox 2"/>
           <p:cNvSpPr txBox="1"/>
           <p:nvPr/>
@@ -6001,7 +5683,7 @@
                 </a:solidFill>
                 <a:latin typeface="Calibri"/>
               </a:rPr>
-              <a:t>•  First: a word for you, the caregiver</a:t>
+              <a:t>•  The signs of running on empty — and what helps</a:t>
             </a:r>
           </a:p>
           <a:p>
@@ -6013,7 +5695,7 @@
                 </a:solidFill>
                 <a:latin typeface="Calibri"/>
               </a:rPr>
-              <a:t>•  The benefits map: SSI, SSDI &amp; DAC in plain words</a:t>
+              <a:t>•  Making medication time easier (your check is free)</a:t>
             </a:r>
           </a:p>
           <a:p>
@@ -6025,7 +5707,7 @@
                 </a:solidFill>
                 <a:latin typeface="Calibri"/>
               </a:rPr>
-              <a:t>•  Medication help — your check is free</a:t>
+              <a:t>•  Money basics for caregiving families</a:t>
             </a:r>
           </a:p>
           <a:p>
@@ -6037,7 +5719,7 @@
                 </a:solidFill>
                 <a:latin typeface="Calibri"/>
               </a:rPr>
-              <a:t>•  Caring for YOU: budget basics &amp; asking for help</a:t>
+              <a:t>•  Where help lives: 2-1-1, respite, parent support</a:t>
             </a:r>
           </a:p>
           <a:p>
@@ -6049,7 +5731,7 @@
                 </a:solidFill>
                 <a:latin typeface="Calibri"/>
               </a:rPr>
-              <a:t>•  Your child's personal plan</a:t>
+              <a:t>•  One small break you can take this month</a:t>
             </a:r>
           </a:p>
           <a:p>
@@ -6237,7 +5919,7 @@
                 </a:solidFill>
                 <a:latin typeface="Georgia"/>
               </a:rPr>
-              <a:t>First, a Word for YOU</a:t>
+              <a:t>Why Tonight Is About You</a:t>
             </a:r>
           </a:p>
         </p:txBody>
@@ -6272,7 +5954,7 @@
                 </a:solidFill>
                 <a:latin typeface="Calibri"/>
               </a:rPr>
-              <a:t>•  You give all day, every day</a:t>
+              <a:t>•  You give all day, every day — meds, rides, calls, papers</a:t>
             </a:r>
           </a:p>
           <a:p>
@@ -6284,7 +5966,7 @@
                 </a:solidFill>
                 <a:latin typeface="Calibri"/>
               </a:rPr>
-              <a:t>•  Caregivers get tired — that is normal, not weak</a:t>
+              <a:t>•  Your child needs you healthy and standing</a:t>
             </a:r>
           </a:p>
           <a:p>
@@ -6308,7 +5990,7 @@
                 </a:solidFill>
                 <a:latin typeface="Calibri"/>
               </a:rPr>
-              <a:t>•  Tonight, some of this help is for YOU</a:t>
+              <a:t>•  Caring for yourself IS caring for your child</a:t>
             </a:r>
           </a:p>
         </p:txBody>
@@ -6484,7 +6166,7 @@
                 </a:solidFill>
                 <a:latin typeface="Georgia"/>
               </a:rPr>
-              <a:t>The Benefits Map</a:t>
+              <a:t>Signs You Are Running on Empty</a:t>
             </a:r>
           </a:p>
         </p:txBody>
@@ -6519,7 +6201,7 @@
                 </a:solidFill>
                 <a:latin typeface="Calibri"/>
               </a:rPr>
-              <a:t>•  Three names come up again and again:</a:t>
+              <a:t>•  Tired all the time, even after sleep</a:t>
             </a:r>
           </a:p>
           <a:p>
@@ -6531,7 +6213,7 @@
                 </a:solidFill>
                 <a:latin typeface="Calibri"/>
               </a:rPr>
-              <a:t>•  SSI — Supplemental Security Income</a:t>
+              <a:t>•  No real break in weeks</a:t>
             </a:r>
           </a:p>
           <a:p>
@@ -6543,7 +6225,7 @@
                 </a:solidFill>
                 <a:latin typeface="Calibri"/>
               </a:rPr>
-              <a:t>•  SSDI — Social Security Disability Insurance</a:t>
+              <a:t>•  Snapping at people you love</a:t>
             </a:r>
           </a:p>
           <a:p>
@@ -6555,7 +6237,7 @@
                 </a:solidFill>
                 <a:latin typeface="Calibri"/>
               </a:rPr>
-              <a:t>•  DAC — Disabled Adult Child benefits</a:t>
+              <a:t>•  Forgetting your OWN medicines and appointments</a:t>
             </a:r>
           </a:p>
           <a:p>
@@ -6567,7 +6249,7 @@
                 </a:solidFill>
                 <a:latin typeface="Calibri"/>
               </a:rPr>
-              <a:t>•  Each one has its own rules</a:t>
+              <a:t>•  Feeling like nobody understands</a:t>
             </a:r>
           </a:p>
         </p:txBody>
@@ -6743,7 +6425,7 @@
                 </a:solidFill>
                 <a:latin typeface="Georgia"/>
               </a:rPr>
-              <a:t>SSI in Plain Words</a:t>
+              <a:t>First Help: Make Medication Time Easier</a:t>
             </a:r>
           </a:p>
         </p:txBody>
@@ -6778,7 +6460,7 @@
                 </a:solidFill>
                 <a:latin typeface="Calibri"/>
               </a:rPr>
-              <a:t>•  SSI is based on need</a:t>
+              <a:t>•  One clean list: name, dose, and what it is for</a:t>
             </a:r>
           </a:p>
           <a:p>
@@ -6790,7 +6472,7 @@
                 </a:solidFill>
                 <a:latin typeface="Calibri"/>
               </a:rPr>
-              <a:t>•  It helps children and adults with disabilities</a:t>
+              <a:t>•  Same time each day, tied to a routine you already do</a:t>
             </a:r>
           </a:p>
           <a:p>
@@ -6802,7 +6484,7 @@
                 </a:solidFill>
                 <a:latin typeface="Calibri"/>
               </a:rPr>
-              <a:t>•  Income and resources count</a:t>
+              <a:t>•  Ask the pharmacy your questions — that is their job</a:t>
             </a:r>
           </a:p>
           <a:p>
@@ -6814,19 +6496,7 @@
                 </a:solidFill>
                 <a:latin typeface="Calibri"/>
               </a:rPr>
-              <a:t>•  Many children with disabilities qualify</a:t>
-            </a:r>
-          </a:p>
-          <a:p>
-            <a:pPr algn="l"/>
-            <a:r>
-              <a:rPr sz="2700" b="0">
-                <a:solidFill>
-                  <a:srgbClr val="222222"/>
-                </a:solidFill>
-                <a:latin typeface="Calibri"/>
-              </a:rPr>
-              <a:t>•  Applying takes papers and patience — and help exists</a:t>
+              <a:t>•  Keep the list on your phone AND on paper</a:t>
             </a:r>
           </a:p>
         </p:txBody>
@@ -7002,7 +6672,7 @@
                 </a:solidFill>
                 <a:latin typeface="Georgia"/>
               </a:rPr>
-              <a:t>SSDI &amp; DAC in Plain Words</a:t>
+              <a:t>Your Free Medication Check</a:t>
             </a:r>
           </a:p>
         </p:txBody>
@@ -7037,7 +6707,7 @@
                 </a:solidFill>
                 <a:latin typeface="Calibri"/>
               </a:rPr>
-              <a:t>•  SSDI is based on a work record</a:t>
+              <a:t>•  We look at your child's full medication list with you</a:t>
             </a:r>
           </a:p>
           <a:p>
@@ -7049,7 +6719,7 @@
                 </a:solidFill>
                 <a:latin typeface="Calibri"/>
               </a:rPr>
-              <a:t>•  DAC is for an adult child with a disability that began before age 22</a:t>
+              <a:t>•  We look for programs that can lower the cost</a:t>
             </a:r>
           </a:p>
           <a:p>
@@ -7061,7 +6731,7 @@
                 </a:solidFill>
                 <a:latin typeface="Calibri"/>
               </a:rPr>
-              <a:t>•  DAC pays on a parent's work record</a:t>
+              <a:t>•  Many families pay more than they have to</a:t>
             </a:r>
           </a:p>
           <a:p>
@@ -7073,19 +6743,7 @@
                 </a:solidFill>
                 <a:latin typeface="Calibri"/>
               </a:rPr>
-              <a:t>•  A parent must be retired, disabled, or passed away</a:t>
-            </a:r>
-          </a:p>
-          <a:p>
-            <a:pPr algn="l"/>
-            <a:r>
-              <a:rPr sz="2700" b="0">
-                <a:solidFill>
-                  <a:srgbClr val="222222"/>
-                </a:solidFill>
-                <a:latin typeface="Calibri"/>
-              </a:rPr>
-              <a:t>•  DAC can connect to Medicaid — timing matters, ask before filing</a:t>
+              <a:t>•  The check is FREE for everyone — always</a:t>
             </a:r>
           </a:p>
         </p:txBody>
@@ -7261,7 +6919,7 @@
                 </a:solidFill>
                 <a:latin typeface="Georgia"/>
               </a:rPr>
-              <a:t>Which One Fits Your Family?</a:t>
+              <a:t>Money Basics for Caregiving Families</a:t>
             </a:r>
           </a:p>
         </p:txBody>
@@ -7296,7 +6954,7 @@
                 </a:solidFill>
                 <a:latin typeface="Calibri"/>
               </a:rPr>
-              <a:t>•  Is the child under 18, or a young adult?</a:t>
+              <a:t>•  Know what comes in and what goes out</a:t>
             </a:r>
           </a:p>
           <a:p>
@@ -7308,7 +6966,7 @@
                 </a:solidFill>
                 <a:latin typeface="Calibri"/>
               </a:rPr>
-              <a:t>•  Has a parent worked and paid into Social Security?</a:t>
+              <a:t>•  Write the bills on one page — that page is your map</a:t>
             </a:r>
           </a:p>
           <a:p>
@@ -7320,7 +6978,7 @@
                 </a:solidFill>
                 <a:latin typeface="Calibri"/>
               </a:rPr>
-              <a:t>•  Is a parent near retirement?</a:t>
+              <a:t>•  Look for the bills that can be lowered first</a:t>
             </a:r>
           </a:p>
           <a:p>
@@ -7332,7 +6990,7 @@
                 </a:solidFill>
                 <a:latin typeface="Calibri"/>
               </a:rPr>
-              <a:t>•  Write your answers down — bring them to your free first talk</a:t>
+              <a:t>•  Small steps beat big stress</a:t>
             </a:r>
           </a:p>
         </p:txBody>
@@ -7508,7 +7166,7 @@
                 </a:solidFill>
                 <a:latin typeface="Georgia"/>
               </a:rPr>
-              <a:t>Medication Help</a:t>
+              <a:t>Call and Ask: Bill Companies</a:t>
             </a:r>
           </a:p>
         </p:txBody>
@@ -7543,7 +7201,7 @@
                 </a:solidFill>
                 <a:latin typeface="Calibri"/>
               </a:rPr>
-              <a:t>•  Medication costs can often be lowered</a:t>
+              <a:t>•  Many companies have hardship or discount programs</a:t>
             </a:r>
           </a:p>
           <a:p>
@@ -7555,7 +7213,7 @@
                 </a:solidFill>
                 <a:latin typeface="Calibri"/>
               </a:rPr>
-              <a:t>•  Help programs exist for many medicines</a:t>
+              <a:t>•  You can ask for a lower price or more time</a:t>
             </a:r>
           </a:p>
           <a:p>
@@ -7567,7 +7225,7 @@
                 </a:solidFill>
                 <a:latin typeface="Calibri"/>
               </a:rPr>
-              <a:t>•  A medication check looks at every medicine your child takes</a:t>
+              <a:t>•  Be kind, be honest, write down who you talked to</a:t>
             </a:r>
           </a:p>
           <a:p>
@@ -7579,19 +7237,7 @@
                 </a:solidFill>
                 <a:latin typeface="Calibri"/>
               </a:rPr>
-              <a:t>•  Your medication check at Southern Oak is always FREE</a:t>
-            </a:r>
-          </a:p>
-          <a:p>
-            <a:pPr algn="l"/>
-            <a:r>
-              <a:rPr sz="2700" b="0">
-                <a:solidFill>
-                  <a:srgbClr val="222222"/>
-                </a:solidFill>
-                <a:latin typeface="Calibri"/>
-              </a:rPr>
-              <a:t>•  Bring your medication list — we go through it together</a:t>
+              <a:t>•  One call can free up real money every month</a:t>
             </a:r>
           </a:p>
         </p:txBody>
@@ -7767,7 +7413,7 @@
                 </a:solidFill>
                 <a:latin typeface="Georgia"/>
               </a:rPr>
-              <a:t>Caring for YOU: Budget Basics</a:t>
+              <a:t>Where Help Lives: 2-1-1</a:t>
             </a:r>
           </a:p>
         </p:txBody>
@@ -7802,7 +7448,7 @@
                 </a:solidFill>
                 <a:latin typeface="Calibri"/>
               </a:rPr>
-              <a:t>•  Know what comes in and what goes out</a:t>
+              <a:t>•  Dial 2-1-1 — free, local, real people</a:t>
             </a:r>
           </a:p>
           <a:p>
@@ -7814,7 +7460,7 @@
                 </a:solidFill>
                 <a:latin typeface="Calibri"/>
               </a:rPr>
-              <a:t>•  Write the bills down — one page is enough to start</a:t>
+              <a:t>•  Food, bills, rides, respite and more</a:t>
             </a:r>
           </a:p>
           <a:p>
@@ -7826,7 +7472,7 @@
                 </a:solidFill>
                 <a:latin typeface="Calibri"/>
               </a:rPr>
-              <a:t>•  You can call bill companies and ask for lower prices or more time</a:t>
+              <a:t>•  Help for San Antonio and the Rio Grande Valley</a:t>
             </a:r>
           </a:p>
           <a:p>
@@ -7838,19 +7484,7 @@
                 </a:solidFill>
                 <a:latin typeface="Calibri"/>
               </a:rPr>
-              <a:t>•  Small steps beat big stress</a:t>
-            </a:r>
-          </a:p>
-          <a:p>
-            <a:pPr algn="l"/>
-            <a:r>
-              <a:rPr sz="2700" b="0">
-                <a:solidFill>
-                  <a:srgbClr val="222222"/>
-                </a:solidFill>
-                <a:latin typeface="Calibri"/>
-              </a:rPr>
-              <a:t>•  Budget help is one of the things we do with families</a:t>
+              <a:t>•  You do not have to know what to ask for — just call</a:t>
             </a:r>
           </a:p>
         </p:txBody>

</xml_diff>

<commit_message>
Retitle Nov 13 webinar assets to Protecting Your Income
</commit_message>
<xml_diff>
--- a/assets/Caregiver-Webinar-Nov13.pptx
+++ b/assets/Caregiver-Webinar-Nov13.pptx
@@ -4278,29 +4278,13 @@
               </a:lnSpc>
             </a:pPr>
             <a:r>
-              <a:rPr sz="4300" b="1" i="0">
+              <a:rPr sz="4800" b="1" i="0">
                 <a:solidFill>
                   <a:srgbClr val="FFFFFF"/>
                 </a:solidFill>
                 <a:latin typeface="Georgia"/>
               </a:rPr>
-              <a:t>Caregivers:</a:t>
-            </a:r>
-          </a:p>
-          <a:p>
-            <a:pPr algn="ctr">
-              <a:lnSpc>
-                <a:spcPct val="115000"/>
-              </a:lnSpc>
-            </a:pPr>
-            <a:r>
-              <a:rPr sz="4300" b="1" i="0">
-                <a:solidFill>
-                  <a:srgbClr val="FFFFFF"/>
-                </a:solidFill>
-                <a:latin typeface="Georgia"/>
-              </a:rPr>
-              <a:t>Why You Need Life Insurance Coverage</a:t>
+              <a:t>Protecting Your Income</a:t>
             </a:r>
           </a:p>
         </p:txBody>
@@ -4339,7 +4323,7 @@
                 </a:solidFill>
                 <a:latin typeface="Verdana"/>
               </a:rPr>
-              <a:t>A Free Zoom Webinar for Family Caregivers</a:t>
+              <a:t>Be prepared when life happens — Living Benefits can help.</a:t>
             </a:r>
           </a:p>
         </p:txBody>

</xml_diff>